<commit_message>
Add lecture 2: loops
</commit_message>
<xml_diff>
--- a/1_conditions/1_conditions.pptx
+++ b/1_conditions/1_conditions.pptx
@@ -5,7 +5,7 @@
     <p:sldMasterId id="2147483660" r:id="rId1"/>
   </p:sldMasterIdLst>
   <p:notesMasterIdLst>
-    <p:notesMasterId r:id="rId28"/>
+    <p:notesMasterId r:id="rId29"/>
   </p:notesMasterIdLst>
   <p:sldIdLst>
     <p:sldId id="256" r:id="rId2"/>
@@ -34,6 +34,7 @@
     <p:sldId id="273" r:id="rId25"/>
     <p:sldId id="304" r:id="rId26"/>
     <p:sldId id="305" r:id="rId27"/>
+    <p:sldId id="306" r:id="rId28"/>
   </p:sldIdLst>
   <p:sldSz cx="12192000" cy="6858000"/>
   <p:notesSz cx="6858000" cy="9144000"/>
@@ -234,7 +235,7 @@
           <a:p>
             <a:fld id="{85EF5437-F444-4613-A039-4AD69D91C86A}" type="datetimeFigureOut">
               <a:rPr lang="ru-RU" smtClean="0"/>
-              <a:t>07.09.2025</a:t>
+              <a:t>08.09.2025</a:t>
             </a:fld>
             <a:endParaRPr lang="ru-RU"/>
           </a:p>
@@ -2097,6 +2098,90 @@
 </p:notes>
 </file>
 
+<file path=ppt/notesSlides/notesSlide27.xml><?xml version="1.0" encoding="utf-8"?>
+<p:notes xmlns:a="http://schemas.openxmlformats.org/drawingml/2006/main" xmlns:r="http://schemas.openxmlformats.org/officeDocument/2006/relationships" xmlns:p="http://schemas.openxmlformats.org/presentationml/2006/main">
+  <p:cSld>
+    <p:spTree>
+      <p:nvGrpSpPr>
+        <p:cNvPr id="1" name=""/>
+        <p:cNvGrpSpPr/>
+        <p:nvPr/>
+      </p:nvGrpSpPr>
+      <p:grpSpPr>
+        <a:xfrm>
+          <a:off x="0" y="0"/>
+          <a:ext cx="0" cy="0"/>
+          <a:chOff x="0" y="0"/>
+          <a:chExt cx="0" cy="0"/>
+        </a:xfrm>
+      </p:grpSpPr>
+      <p:sp>
+        <p:nvSpPr>
+          <p:cNvPr id="2" name="Образ слайда 1"/>
+          <p:cNvSpPr>
+            <a:spLocks noGrp="1" noRot="1" noChangeAspect="1"/>
+          </p:cNvSpPr>
+          <p:nvPr>
+            <p:ph type="sldImg"/>
+          </p:nvPr>
+        </p:nvSpPr>
+        <p:spPr/>
+      </p:sp>
+      <p:sp>
+        <p:nvSpPr>
+          <p:cNvPr id="3" name="Заметки 2"/>
+          <p:cNvSpPr>
+            <a:spLocks noGrp="1"/>
+          </p:cNvSpPr>
+          <p:nvPr>
+            <p:ph type="body" idx="1"/>
+          </p:nvPr>
+        </p:nvSpPr>
+        <p:spPr/>
+        <p:txBody>
+          <a:bodyPr/>
+          <a:lstStyle/>
+          <a:p>
+            <a:endParaRPr lang="ru-RU" dirty="0"/>
+          </a:p>
+        </p:txBody>
+      </p:sp>
+      <p:sp>
+        <p:nvSpPr>
+          <p:cNvPr id="4" name="Номер слайда 3"/>
+          <p:cNvSpPr>
+            <a:spLocks noGrp="1"/>
+          </p:cNvSpPr>
+          <p:nvPr>
+            <p:ph type="sldNum" sz="quarter" idx="10"/>
+          </p:nvPr>
+        </p:nvSpPr>
+        <p:spPr/>
+        <p:txBody>
+          <a:bodyPr/>
+          <a:lstStyle/>
+          <a:p>
+            <a:fld id="{207EAB29-8E86-49C7-96F5-7C9D72076108}" type="slidenum">
+              <a:rPr lang="ru-RU" smtClean="0"/>
+              <a:t>27</a:t>
+            </a:fld>
+            <a:endParaRPr lang="ru-RU"/>
+          </a:p>
+        </p:txBody>
+      </p:sp>
+    </p:spTree>
+    <p:extLst>
+      <p:ext uri="{BB962C8B-B14F-4D97-AF65-F5344CB8AC3E}">
+        <p14:creationId xmlns:p14="http://schemas.microsoft.com/office/powerpoint/2010/main" val="1218560485"/>
+      </p:ext>
+    </p:extLst>
+  </p:cSld>
+  <p:clrMapOvr>
+    <a:masterClrMapping/>
+  </p:clrMapOvr>
+</p:notes>
+</file>
+
 <file path=ppt/notesSlides/notesSlide3.xml><?xml version="1.0" encoding="utf-8"?>
 <p:notes xmlns:a="http://schemas.openxmlformats.org/drawingml/2006/main" xmlns:r="http://schemas.openxmlformats.org/officeDocument/2006/relationships" xmlns:p="http://schemas.openxmlformats.org/presentationml/2006/main">
   <p:cSld>
@@ -2816,7 +2901,7 @@
           <a:p>
             <a:fld id="{58BF7D01-7D49-4F37-AA30-F04C65571A4A}" type="datetimeFigureOut">
               <a:rPr lang="ru-RU" smtClean="0"/>
-              <a:t>07.09.2025</a:t>
+              <a:t>08.09.2025</a:t>
             </a:fld>
             <a:endParaRPr lang="ru-RU"/>
           </a:p>
@@ -2986,7 +3071,7 @@
           <a:p>
             <a:fld id="{58BF7D01-7D49-4F37-AA30-F04C65571A4A}" type="datetimeFigureOut">
               <a:rPr lang="ru-RU" smtClean="0"/>
-              <a:t>07.09.2025</a:t>
+              <a:t>08.09.2025</a:t>
             </a:fld>
             <a:endParaRPr lang="ru-RU"/>
           </a:p>
@@ -3166,7 +3251,7 @@
           <a:p>
             <a:fld id="{58BF7D01-7D49-4F37-AA30-F04C65571A4A}" type="datetimeFigureOut">
               <a:rPr lang="ru-RU" smtClean="0"/>
-              <a:t>07.09.2025</a:t>
+              <a:t>08.09.2025</a:t>
             </a:fld>
             <a:endParaRPr lang="ru-RU"/>
           </a:p>
@@ -3336,7 +3421,7 @@
           <a:p>
             <a:fld id="{58BF7D01-7D49-4F37-AA30-F04C65571A4A}" type="datetimeFigureOut">
               <a:rPr lang="ru-RU" smtClean="0"/>
-              <a:t>07.09.2025</a:t>
+              <a:t>08.09.2025</a:t>
             </a:fld>
             <a:endParaRPr lang="ru-RU"/>
           </a:p>
@@ -3582,7 +3667,7 @@
           <a:p>
             <a:fld id="{58BF7D01-7D49-4F37-AA30-F04C65571A4A}" type="datetimeFigureOut">
               <a:rPr lang="ru-RU" smtClean="0"/>
-              <a:t>07.09.2025</a:t>
+              <a:t>08.09.2025</a:t>
             </a:fld>
             <a:endParaRPr lang="ru-RU"/>
           </a:p>
@@ -3814,7 +3899,7 @@
           <a:p>
             <a:fld id="{58BF7D01-7D49-4F37-AA30-F04C65571A4A}" type="datetimeFigureOut">
               <a:rPr lang="ru-RU" smtClean="0"/>
-              <a:t>07.09.2025</a:t>
+              <a:t>08.09.2025</a:t>
             </a:fld>
             <a:endParaRPr lang="ru-RU"/>
           </a:p>
@@ -4181,7 +4266,7 @@
           <a:p>
             <a:fld id="{58BF7D01-7D49-4F37-AA30-F04C65571A4A}" type="datetimeFigureOut">
               <a:rPr lang="ru-RU" smtClean="0"/>
-              <a:t>07.09.2025</a:t>
+              <a:t>08.09.2025</a:t>
             </a:fld>
             <a:endParaRPr lang="ru-RU"/>
           </a:p>
@@ -4299,7 +4384,7 @@
           <a:p>
             <a:fld id="{58BF7D01-7D49-4F37-AA30-F04C65571A4A}" type="datetimeFigureOut">
               <a:rPr lang="ru-RU" smtClean="0"/>
-              <a:t>07.09.2025</a:t>
+              <a:t>08.09.2025</a:t>
             </a:fld>
             <a:endParaRPr lang="ru-RU"/>
           </a:p>
@@ -4394,7 +4479,7 @@
           <a:p>
             <a:fld id="{58BF7D01-7D49-4F37-AA30-F04C65571A4A}" type="datetimeFigureOut">
               <a:rPr lang="ru-RU" smtClean="0"/>
-              <a:t>07.09.2025</a:t>
+              <a:t>08.09.2025</a:t>
             </a:fld>
             <a:endParaRPr lang="ru-RU"/>
           </a:p>
@@ -4671,7 +4756,7 @@
           <a:p>
             <a:fld id="{58BF7D01-7D49-4F37-AA30-F04C65571A4A}" type="datetimeFigureOut">
               <a:rPr lang="ru-RU" smtClean="0"/>
-              <a:t>07.09.2025</a:t>
+              <a:t>08.09.2025</a:t>
             </a:fld>
             <a:endParaRPr lang="ru-RU"/>
           </a:p>
@@ -4928,7 +5013,7 @@
           <a:p>
             <a:fld id="{58BF7D01-7D49-4F37-AA30-F04C65571A4A}" type="datetimeFigureOut">
               <a:rPr lang="ru-RU" smtClean="0"/>
-              <a:t>07.09.2025</a:t>
+              <a:t>08.09.2025</a:t>
             </a:fld>
             <a:endParaRPr lang="ru-RU"/>
           </a:p>
@@ -5141,7 +5226,7 @@
           <a:p>
             <a:fld id="{58BF7D01-7D49-4F37-AA30-F04C65571A4A}" type="datetimeFigureOut">
               <a:rPr lang="ru-RU" smtClean="0"/>
-              <a:t>07.09.2025</a:t>
+              <a:t>08.09.2025</a:t>
             </a:fld>
             <a:endParaRPr lang="ru-RU"/>
           </a:p>
@@ -16850,6 +16935,182 @@
     <p:extLst>
       <p:ext uri="{BB962C8B-B14F-4D97-AF65-F5344CB8AC3E}">
         <p14:creationId xmlns:p14="http://schemas.microsoft.com/office/powerpoint/2010/main" val="808897176"/>
+      </p:ext>
+    </p:extLst>
+  </p:cSld>
+  <p:clrMapOvr>
+    <a:masterClrMapping/>
+  </p:clrMapOvr>
+</p:sld>
+</file>
+
+<file path=ppt/slides/slide27.xml><?xml version="1.0" encoding="utf-8"?>
+<p:sld xmlns:a="http://schemas.openxmlformats.org/drawingml/2006/main" xmlns:r="http://schemas.openxmlformats.org/officeDocument/2006/relationships" xmlns:p="http://schemas.openxmlformats.org/presentationml/2006/main">
+  <p:cSld>
+    <p:spTree>
+      <p:nvGrpSpPr>
+        <p:cNvPr id="1" name=""/>
+        <p:cNvGrpSpPr/>
+        <p:nvPr/>
+      </p:nvGrpSpPr>
+      <p:grpSpPr>
+        <a:xfrm>
+          <a:off x="0" y="0"/>
+          <a:ext cx="0" cy="0"/>
+          <a:chOff x="0" y="0"/>
+          <a:chExt cx="0" cy="0"/>
+        </a:xfrm>
+      </p:grpSpPr>
+      <p:sp>
+        <p:nvSpPr>
+          <p:cNvPr id="3" name="Заголовок 2">
+            <a:extLst>
+              <a:ext uri="{FF2B5EF4-FFF2-40B4-BE49-F238E27FC236}">
+                <a16:creationId xmlns:a16="http://schemas.microsoft.com/office/drawing/2014/main" id="{A813CAB2-2AD3-CBC2-8DE8-2FF5AB76B7A0}"/>
+              </a:ext>
+            </a:extLst>
+          </p:cNvPr>
+          <p:cNvSpPr>
+            <a:spLocks noGrp="1"/>
+          </p:cNvSpPr>
+          <p:nvPr>
+            <p:ph type="ctrTitle"/>
+          </p:nvPr>
+        </p:nvSpPr>
+        <p:spPr>
+          <a:xfrm>
+            <a:off x="5114708" y="732353"/>
+            <a:ext cx="2503404" cy="927688"/>
+          </a:xfrm>
+        </p:spPr>
+        <p:txBody>
+          <a:bodyPr/>
+          <a:lstStyle/>
+          <a:p>
+            <a:r>
+              <a:rPr lang="en-US" dirty="0" err="1"/>
+              <a:t>Github</a:t>
+            </a:r>
+            <a:endParaRPr lang="ru-RU" dirty="0"/>
+          </a:p>
+        </p:txBody>
+      </p:sp>
+      <p:pic>
+        <p:nvPicPr>
+          <p:cNvPr id="13314" name="Picture 2" descr="GitHub - Apps on Google Play">
+            <a:extLst>
+              <a:ext uri="{FF2B5EF4-FFF2-40B4-BE49-F238E27FC236}">
+                <a16:creationId xmlns:a16="http://schemas.microsoft.com/office/drawing/2014/main" id="{73638D15-9EFA-B53C-910B-8E549447960B}"/>
+              </a:ext>
+            </a:extLst>
+          </p:cNvPr>
+          <p:cNvPicPr>
+            <a:picLocks noChangeAspect="1" noChangeArrowheads="1"/>
+          </p:cNvPicPr>
+          <p:nvPr/>
+        </p:nvPicPr>
+        <p:blipFill>
+          <a:blip r:embed="rId3">
+            <a:extLst>
+              <a:ext uri="{28A0092B-C50C-407E-A947-70E740481C1C}">
+                <a14:useLocalDpi xmlns:a14="http://schemas.microsoft.com/office/drawing/2010/main" val="0"/>
+              </a:ext>
+            </a:extLst>
+          </a:blip>
+          <a:srcRect/>
+          <a:stretch>
+            <a:fillRect/>
+          </a:stretch>
+        </p:blipFill>
+        <p:spPr bwMode="auto">
+          <a:xfrm>
+            <a:off x="2741645" y="2761214"/>
+            <a:ext cx="3354355" cy="3354355"/>
+          </a:xfrm>
+          <a:prstGeom prst="rect">
+            <a:avLst/>
+          </a:prstGeom>
+          <a:noFill/>
+          <a:extLst>
+            <a:ext uri="{909E8E84-426E-40DD-AFC4-6F175D3DCCD1}">
+              <a14:hiddenFill xmlns:a14="http://schemas.microsoft.com/office/drawing/2010/main">
+                <a:solidFill>
+                  <a:srgbClr val="FFFFFF"/>
+                </a:solidFill>
+              </a14:hiddenFill>
+            </a:ext>
+          </a:extLst>
+        </p:spPr>
+      </p:pic>
+      <p:pic>
+        <p:nvPicPr>
+          <p:cNvPr id="4" name="Рисунок 3">
+            <a:extLst>
+              <a:ext uri="{FF2B5EF4-FFF2-40B4-BE49-F238E27FC236}">
+                <a16:creationId xmlns:a16="http://schemas.microsoft.com/office/drawing/2014/main" id="{46C90E63-E5A3-4470-AD6D-63EB1FD9D1A1}"/>
+              </a:ext>
+            </a:extLst>
+          </p:cNvPr>
+          <p:cNvPicPr>
+            <a:picLocks noChangeAspect="1"/>
+          </p:cNvPicPr>
+          <p:nvPr/>
+        </p:nvPicPr>
+        <p:blipFill>
+          <a:blip r:embed="rId4"/>
+          <a:stretch>
+            <a:fillRect/>
+          </a:stretch>
+        </p:blipFill>
+        <p:spPr>
+          <a:xfrm>
+            <a:off x="6477000" y="2805521"/>
+            <a:ext cx="3280547" cy="3265742"/>
+          </a:xfrm>
+          <a:prstGeom prst="rect">
+            <a:avLst/>
+          </a:prstGeom>
+        </p:spPr>
+      </p:pic>
+      <p:sp>
+        <p:nvSpPr>
+          <p:cNvPr id="6" name="TextBox 5">
+            <a:extLst>
+              <a:ext uri="{FF2B5EF4-FFF2-40B4-BE49-F238E27FC236}">
+                <a16:creationId xmlns:a16="http://schemas.microsoft.com/office/drawing/2014/main" id="{ED8EE967-943B-407F-8E78-2668FBEBC15D}"/>
+              </a:ext>
+            </a:extLst>
+          </p:cNvPr>
+          <p:cNvSpPr txBox="1"/>
+          <p:nvPr/>
+        </p:nvSpPr>
+        <p:spPr>
+          <a:xfrm>
+            <a:off x="3105916" y="1867461"/>
+            <a:ext cx="6520988" cy="523220"/>
+          </a:xfrm>
+          <a:prstGeom prst="rect">
+            <a:avLst/>
+          </a:prstGeom>
+          <a:noFill/>
+        </p:spPr>
+        <p:txBody>
+          <a:bodyPr wrap="square">
+            <a:spAutoFit/>
+          </a:bodyPr>
+          <a:lstStyle/>
+          <a:p>
+            <a:r>
+              <a:rPr lang="ru-RU" sz="2800" dirty="0"/>
+              <a:t>https://github.com/kruffka/C-Programming</a:t>
+            </a:r>
+          </a:p>
+        </p:txBody>
+      </p:sp>
+    </p:spTree>
+    <p:extLst>
+      <p:ext uri="{BB962C8B-B14F-4D97-AF65-F5344CB8AC3E}">
+        <p14:creationId xmlns:p14="http://schemas.microsoft.com/office/powerpoint/2010/main" val="244768081"/>
       </p:ext>
     </p:extLst>
   </p:cSld>

</xml_diff>